<commit_message>
Redesign deck to Expedia consumer light theme; name-only byline
Rebuilt the 7-page deck around Expedia's real consumer-site look shared
by the user (white cards, navy text, action-blue #1668E3 accents, yellow
#FDB92C highlights and a recreated Expedia tile mark) instead of the dark
theme. Structured strictly around the five required deliverable sections
in a problem-first flow, with all copy free of em dashes and the demo
script's wit preserved:

1. Cover (Expedia mark, name-only byline, live product in a browser frame)
2. I. Problem Statement
3. II. Solution Overview
4. III. Architecture & Workflow
5. IV. Datasets & Inputs Used
6. V. Demo Video (with a link/QR placeholder to fill in)
7. Why It Wins (proof, differentiation, impact, roadmap)

Byline reduced to just "Ishika Sattawan" (dropped "IIT Roorkee" and
"Solo submission") across deck, README, and the demo script for
consistency. Regenerated deck.pdf and deck.pptx; synced deck_outline.md.
</commit_message>
<xml_diff>
--- a/deliverables/deck.pptx
+++ b/deliverables/deck.pptx
@@ -508,7 +508,7 @@
           <a:p>
             <a:r>
               <a:rPr lang="en-US" dirty="0"/>
-              <a:t>PAGE 1 — Title &amp; Product Vision</a:t>
+              <a:t>PAGE 1 : COVER</a:t>
             </a:r>
             <a:endParaRPr lang="en-US" dirty="0"/>
           </a:p>
@@ -596,7 +596,7 @@
           <a:p>
             <a:r>
               <a:rPr lang="en-US" dirty="0"/>
-              <a:t>PAGE 2 — The Core Problem Matrix</a:t>
+              <a:t>PAGE 2 : PROBLEM STATEMENT</a:t>
             </a:r>
             <a:endParaRPr lang="en-US" dirty="0"/>
           </a:p>
@@ -684,7 +684,7 @@
           <a:p>
             <a:r>
               <a:rPr lang="en-US" dirty="0"/>
-              <a:t>PAGE 3 — Engine Architecture</a:t>
+              <a:t>PAGE 3 : SOLUTION OVERVIEW</a:t>
             </a:r>
             <a:endParaRPr lang="en-US" dirty="0"/>
           </a:p>
@@ -772,7 +772,7 @@
           <a:p>
             <a:r>
               <a:rPr lang="en-US" dirty="0"/>
-              <a:t>PAGE 4 — High-Performance Engineering Stack</a:t>
+              <a:t>PAGE 4 : ARCHITECTURE / WORKFLOW</a:t>
             </a:r>
             <a:endParaRPr lang="en-US" dirty="0"/>
           </a:p>
@@ -860,7 +860,7 @@
           <a:p>
             <a:r>
               <a:rPr lang="en-US" dirty="0"/>
-              <a:t>PAGE 5 — Empirical Proof &amp; Validation Matrix</a:t>
+              <a:t>PAGE 5 : DATASETS / INPUTS</a:t>
             </a:r>
             <a:endParaRPr lang="en-US" dirty="0"/>
           </a:p>
@@ -948,7 +948,7 @@
           <a:p>
             <a:r>
               <a:rPr lang="en-US" dirty="0"/>
-              <a:t>PAGE 6 — Expected Value &amp; Commercial Impact</a:t>
+              <a:t>PAGE 6 : DEMO VIDEO</a:t>
             </a:r>
             <a:endParaRPr lang="en-US" dirty="0"/>
           </a:p>
@@ -1036,7 +1036,7 @@
           <a:p>
             <a:r>
               <a:rPr lang="en-US" dirty="0"/>
-              <a:t>PAGE 7 — Engineering Boundaries &amp; Future Roadmap</a:t>
+              <a:t>PAGE 7 : IMPACT &amp; CLOSE</a:t>
             </a:r>
             <a:endParaRPr lang="en-US" dirty="0"/>
           </a:p>

</xml_diff>

<commit_message>
Remove demo video slide from deck (video submitted separately)
Drops the V. Demo Video slide with the link/QR placeholder per request;
the recorded demo is provided as its own file in the submission folder.
Deck is now 6 slides (Problem, Solution, Architecture, Datasets, Why It
Wins, plus cover). Regenerated deck.pdf and deck.pptx.
</commit_message>
<xml_diff>
--- a/deliverables/deck.pptx
+++ b/deliverables/deck.pptx
@@ -11,10 +11,9 @@
     <p:sldId id="259" r:id="rId5"/>
     <p:sldId id="260" r:id="rId6"/>
     <p:sldId id="261" r:id="rId7"/>
-    <p:sldId id="262" r:id="rId8"/>
   </p:sldIdLst>
   <p:notesMasterIdLst>
-    <p:notesMasterId r:id="rId9"/>
+    <p:notesMasterId r:id="rId8"/>
   </p:notesMasterIdLst>
   <p:sldSz cx="12192000" cy="6858000"/>
   <p:notesSz cx="6858000" cy="12192000"/>
@@ -948,7 +947,7 @@
           <a:p>
             <a:r>
               <a:rPr lang="en-US" dirty="0"/>
-              <a:t>PAGE 6 : DEMO VIDEO</a:t>
+              <a:t>PAGE 6 : IMPACT &amp; CLOSE</a:t>
             </a:r>
             <a:endParaRPr lang="en-US" dirty="0"/>
           </a:p>
@@ -972,94 +971,6 @@
             <a:fld id="{F7021451-1387-4CA6-816F-3879F97B5CBC}" type="slidenum">
               <a:rPr lang="en-US"/>
               <a:t>6</a:t>
-            </a:fld>
-            <a:endParaRPr lang="en-US"/>
-          </a:p>
-        </p:txBody>
-      </p:sp>
-    </p:spTree>
-    <p:extLst>
-      <p:ext uri="{BB962C8B-B14F-4D97-AF65-F5344CB8AC3E}">
-        <p14:creationId xmlns:p14="http://schemas.microsoft.com/office/powerpoint/2010/main" val="1024086991"/>
-      </p:ext>
-    </p:extLst>
-  </p:cSld>
-  <p:clrMapOvr>
-    <a:masterClrMapping/>
-  </p:clrMapOvr>
-</p:notes>
-</file>
-
-<file path=ppt/notesSlides/notesSlide7.xml><?xml version="1.0" encoding="utf-8"?>
-<p:notes xmlns:a="http://schemas.openxmlformats.org/drawingml/2006/main" xmlns:r="http://schemas.openxmlformats.org/officeDocument/2006/relationships" xmlns:p="http://schemas.openxmlformats.org/presentationml/2006/main">
-  <p:cSld>
-    <p:spTree>
-      <p:nvGrpSpPr>
-        <p:cNvPr id="1" name=""/>
-        <p:cNvGrpSpPr/>
-        <p:nvPr/>
-      </p:nvGrpSpPr>
-      <p:grpSpPr>
-        <a:xfrm>
-          <a:off x="0" y="0"/>
-          <a:ext cx="0" cy="0"/>
-          <a:chOff x="0" y="0"/>
-          <a:chExt cx="0" cy="0"/>
-        </a:xfrm>
-      </p:grpSpPr>
-      <p:sp>
-        <p:nvSpPr>
-          <p:cNvPr id="2" name="Slide Image Placeholder 1"/>
-          <p:cNvSpPr>
-            <a:spLocks noGrp="1" noRot="1" noChangeAspect="1"/>
-          </p:cNvSpPr>
-          <p:nvPr>
-            <p:ph type="sldImg"/>
-          </p:nvPr>
-        </p:nvSpPr>
-        <p:spPr/>
-      </p:sp>
-      <p:sp>
-        <p:nvSpPr>
-          <p:cNvPr id="3" name="Notes Placeholder 2"/>
-          <p:cNvSpPr>
-            <a:spLocks noGrp="1"/>
-          </p:cNvSpPr>
-          <p:nvPr>
-            <p:ph type="body" idx="1"/>
-          </p:nvPr>
-        </p:nvSpPr>
-        <p:spPr/>
-        <p:txBody>
-          <a:bodyPr/>
-          <a:lstStyle/>
-          <a:p>
-            <a:r>
-              <a:rPr lang="en-US" dirty="0"/>
-              <a:t>PAGE 7 : IMPACT &amp; CLOSE</a:t>
-            </a:r>
-            <a:endParaRPr lang="en-US" dirty="0"/>
-          </a:p>
-        </p:txBody>
-      </p:sp>
-      <p:sp>
-        <p:nvSpPr>
-          <p:cNvPr id="4" name="Slide Number Placeholder 3"/>
-          <p:cNvSpPr>
-            <a:spLocks noGrp="1"/>
-          </p:cNvSpPr>
-          <p:nvPr>
-            <p:ph type="sldNum" sz="quarter" idx="10"/>
-          </p:nvPr>
-        </p:nvSpPr>
-        <p:spPr/>
-        <p:txBody>
-          <a:bodyPr/>
-          <a:lstStyle/>
-          <a:p>
-            <a:fld id="{F7021451-1387-4CA6-816F-3879F97B5CBC}" type="slidenum">
-              <a:rPr lang="en-US"/>
-              <a:t>7</a:t>
             </a:fld>
             <a:endParaRPr lang="en-US"/>
           </a:p>
@@ -1619,45 +1530,6 @@
 </p:sld>
 </file>
 
-<file path=ppt/slides/slide7.xml><?xml version="1.0" encoding="utf-8"?>
-<p:sld xmlns:a="http://schemas.openxmlformats.org/drawingml/2006/main" xmlns:r="http://schemas.openxmlformats.org/officeDocument/2006/relationships" xmlns:p="http://schemas.openxmlformats.org/presentationml/2006/main">
-  <p:cSld name="Slide 7">
-    <p:bg>
-      <p:bgPr>
-        <a:blipFill dpi="0" rotWithShape="1">
-          <a:blip r:embed="rId1">
-            <a:lum/>
-          </a:blip>
-          <a:srcRect/>
-          <a:stretch>
-            <a:fillRect/>
-          </a:stretch>
-        </a:blipFill>
-        <a:effectLst/>
-      </p:bgPr>
-    </p:bg>
-    <p:spTree>
-      <p:nvGrpSpPr>
-        <p:cNvPr id="1" name=""/>
-        <p:cNvGrpSpPr/>
-        <p:nvPr/>
-      </p:nvGrpSpPr>
-      <p:grpSpPr>
-        <a:xfrm>
-          <a:off x="0" y="0"/>
-          <a:ext cx="0" cy="0"/>
-          <a:chOff x="0" y="0"/>
-          <a:chExt cx="0" cy="0"/>
-        </a:xfrm>
-      </p:grpSpPr>
-    </p:spTree>
-  </p:cSld>
-  <p:clrMapOvr>
-    <a:masterClrMapping/>
-  </p:clrMapOvr>
-</p:sld>
-</file>
-
 <file path=ppt/theme/theme1.xml><?xml version="1.0" encoding="utf-8"?>
 <a:theme xmlns:a="http://schemas.openxmlformats.org/drawingml/2006/main" name="Office Theme">
   <a:themeElements>

</xml_diff>